<commit_message>
Section5 (Era III 2035 Prevention) PPTX: hand-tuned 5-slide build matching HTML — Venn, reading queue, full-width fusion engine, whole-body streams, two-tier; all SVGs transparent over gradient bg; stats removed on slides 1 & 5 per HTML
</commit_message>
<xml_diff>
--- a/keynote-iwbi-2026/pptx/sections/IWBI2026_Trivedi_05_EraIII_prevention.pptx
+++ b/keynote-iwbi-2026/pptx/sections/IWBI2026_Trivedi_05_EraIII_prevention.pptx
@@ -3800,16 +3800,40 @@
         <p:nvPr/>
       </p:nvGrpSpPr>
       <p:grpSpPr/>
-      <p:sp>
-        <p:nvSpPr>
-          <p:cNvPr id="2" name="Rectangle 1"/>
+      <p:pic>
+        <p:nvPicPr>
+          <p:cNvPr id="2" name="Picture 1" descr="bg_motif.png"/>
+          <p:cNvPicPr>
+            <a:picLocks noChangeAspect="1"/>
+          </p:cNvPicPr>
+          <p:nvPr/>
+        </p:nvPicPr>
+        <p:blipFill>
+          <a:blip r:embed="rId2"/>
+          <a:stretch>
+            <a:fillRect/>
+          </a:stretch>
+        </p:blipFill>
+        <p:spPr>
+          <a:xfrm>
+            <a:off x="0" y="0"/>
+            <a:ext cx="12191695" cy="6858000"/>
+          </a:xfrm>
+          <a:prstGeom prst="rect">
+            <a:avLst/>
+          </a:prstGeom>
+        </p:spPr>
+      </p:pic>
+      <p:sp>
+        <p:nvSpPr>
+          <p:cNvPr id="3" name="Rectangle 2"/>
           <p:cNvSpPr/>
           <p:nvPr/>
         </p:nvSpPr>
         <p:spPr>
           <a:xfrm>
             <a:off x="0" y="0"/>
-            <a:ext cx="12191695" cy="38100"/>
+            <a:ext cx="5486400" cy="38100"/>
           </a:xfrm>
           <a:prstGeom prst="rect">
             <a:avLst/>
@@ -3846,14 +3870,14 @@
       </p:sp>
       <p:sp>
         <p:nvSpPr>
-          <p:cNvPr id="3" name="TextBox 2"/>
+          <p:cNvPr id="4" name="TextBox 3"/>
           <p:cNvSpPr txBox="1"/>
           <p:nvPr/>
         </p:nvSpPr>
         <p:spPr>
           <a:xfrm>
-            <a:off x="777240" y="411480"/>
-            <a:ext cx="8686800" cy="365760"/>
+            <a:off x="777240" y="502920"/>
+            <a:ext cx="8229600" cy="320040"/>
           </a:xfrm>
           <a:prstGeom prst="rect">
             <a:avLst/>
@@ -3861,21 +3885,18 @@
           <a:noFill/>
         </p:spPr>
         <p:txBody>
-          <a:bodyPr wrap="square" lIns="25400" rIns="25400" tIns="12700" bIns="12700">
-            <a:noAutofit/>
+          <a:bodyPr wrap="square" anchor="t" lIns="0" rIns="0" tIns="0" bIns="0">
+            <a:spAutoFit/>
           </a:bodyPr>
           <a:lstStyle/>
           <a:p>
             <a:pPr algn="l">
               <a:lnSpc>
-                <a:spcPct val="128000"/>
+                <a:spcPct val="100000"/>
               </a:lnSpc>
-              <a:spcAft>
-                <a:spcPts val="400"/>
-              </a:spcAft>
             </a:pPr>
             <a:r>
-              <a:rPr sz="1100" b="1">
+              <a:rPr sz="1100" b="1" i="0">
                 <a:solidFill>
                   <a:srgbClr val="E7AC51"/>
                 </a:solidFill>
@@ -3888,14 +3909,14 @@
       </p:sp>
       <p:sp>
         <p:nvSpPr>
-          <p:cNvPr id="4" name="TextBox 3"/>
+          <p:cNvPr id="5" name="TextBox 4"/>
           <p:cNvSpPr txBox="1"/>
           <p:nvPr/>
         </p:nvSpPr>
         <p:spPr>
           <a:xfrm>
-            <a:off x="777240" y="2639568"/>
-            <a:ext cx="5989320" cy="904240"/>
+            <a:off x="777240" y="1828800"/>
+            <a:ext cx="5943600" cy="1371600"/>
           </a:xfrm>
           <a:prstGeom prst="rect">
             <a:avLst/>
@@ -3903,21 +3924,18 @@
           <a:noFill/>
         </p:spPr>
         <p:txBody>
-          <a:bodyPr wrap="square" lIns="25400" rIns="25400" tIns="12700" bIns="12700">
-            <a:noAutofit/>
+          <a:bodyPr wrap="square" anchor="t" lIns="0" rIns="0" tIns="0" bIns="0">
+            <a:spAutoFit/>
           </a:bodyPr>
           <a:lstStyle/>
           <a:p>
             <a:pPr algn="l">
               <a:lnSpc>
-                <a:spcPct val="106000"/>
+                <a:spcPct val="112000"/>
               </a:lnSpc>
-              <a:spcAft>
-                <a:spcPts val="400"/>
-              </a:spcAft>
             </a:pPr>
             <a:r>
-              <a:rPr sz="2600" b="0">
+              <a:rPr sz="2700" b="1" i="0">
                 <a:solidFill>
                   <a:srgbClr val="ECEFF3"/>
                 </a:solidFill>
@@ -3926,7 +3944,7 @@
               <a:t>She knows her risk </a:t>
             </a:r>
             <a:r>
-              <a:rPr sz="2600" b="0">
+              <a:rPr sz="2700" b="1" i="0">
                 <a:solidFill>
                   <a:srgbClr val="E7AC51"/>
                 </a:solidFill>
@@ -3939,14 +3957,14 @@
       </p:sp>
       <p:sp>
         <p:nvSpPr>
-          <p:cNvPr id="5" name="TextBox 4"/>
+          <p:cNvPr id="6" name="TextBox 5"/>
           <p:cNvSpPr txBox="1"/>
           <p:nvPr/>
         </p:nvSpPr>
         <p:spPr>
           <a:xfrm>
-            <a:off x="777240" y="3543808"/>
-            <a:ext cx="5989320" cy="801623"/>
+            <a:off x="777240" y="3200400"/>
+            <a:ext cx="5943600" cy="1828800"/>
           </a:xfrm>
           <a:prstGeom prst="rect">
             <a:avLst/>
@@ -3954,21 +3972,18 @@
           <a:noFill/>
         </p:spPr>
         <p:txBody>
-          <a:bodyPr wrap="square" lIns="25400" rIns="25400" tIns="12700" bIns="12700">
-            <a:noAutofit/>
+          <a:bodyPr wrap="square" anchor="t" lIns="0" rIns="0" tIns="0" bIns="0">
+            <a:spAutoFit/>
           </a:bodyPr>
           <a:lstStyle/>
           <a:p>
             <a:pPr algn="l">
               <a:lnSpc>
-                <a:spcPct val="128000"/>
+                <a:spcPct val="145000"/>
               </a:lnSpc>
-              <a:spcAft>
-                <a:spcPts val="400"/>
-              </a:spcAft>
             </a:pPr>
             <a:r>
-              <a:rPr sz="1400" b="0">
+              <a:rPr sz="1500" b="0" i="0">
                 <a:solidFill>
                   <a:srgbClr val="9DA9B5"/>
                 </a:solidFill>
@@ -3977,7 +3992,7 @@
               <a:t>Risk in 2035 is built from </a:t>
             </a:r>
             <a:r>
-              <a:rPr sz="1400" b="1">
+              <a:rPr sz="1500" b="1" i="0">
                 <a:solidFill>
                   <a:srgbClr val="ECEFF3"/>
                 </a:solidFill>
@@ -3986,7 +4001,7 @@
               <a:t>four independent inputs</a:t>
             </a:r>
             <a:r>
-              <a:rPr sz="1400" b="0">
+              <a:rPr sz="1500" b="0" i="0">
                 <a:solidFill>
                   <a:srgbClr val="9DA9B5"/>
                 </a:solidFill>
@@ -3995,7 +4010,7 @@
               <a:t> — polygenic, germline, clinical, and </a:t>
             </a:r>
             <a:r>
-              <a:rPr sz="1400" b="1">
+              <a:rPr sz="1500" b="1" i="0">
                 <a:solidFill>
                   <a:srgbClr val="ECEFF3"/>
                 </a:solidFill>
@@ -4004,7 +4019,7 @@
               <a:t>imaging</a:t>
             </a:r>
             <a:r>
-              <a:rPr sz="1400" b="0">
+              <a:rPr sz="1500" b="0" i="0">
                 <a:solidFill>
                   <a:srgbClr val="9DA9B5"/>
                 </a:solidFill>
@@ -4017,14 +4032,14 @@
       </p:sp>
       <p:sp>
         <p:nvSpPr>
-          <p:cNvPr id="6" name="TextBox 5"/>
+          <p:cNvPr id="7" name="TextBox 6"/>
           <p:cNvSpPr txBox="1"/>
           <p:nvPr/>
         </p:nvSpPr>
         <p:spPr>
           <a:xfrm>
-            <a:off x="777240" y="4345432"/>
-            <a:ext cx="5989320" cy="421640"/>
+            <a:off x="777240" y="4937760"/>
+            <a:ext cx="5943600" cy="548640"/>
           </a:xfrm>
           <a:prstGeom prst="rect">
             <a:avLst/>
@@ -4032,8 +4047,8 @@
           <a:noFill/>
         </p:spPr>
         <p:txBody>
-          <a:bodyPr wrap="square" lIns="25400" rIns="25400" tIns="12700" bIns="12700">
-            <a:noAutofit/>
+          <a:bodyPr wrap="square" anchor="t" lIns="0" rIns="0" tIns="0" bIns="0">
+            <a:spAutoFit/>
           </a:bodyPr>
           <a:lstStyle/>
           <a:p>
@@ -4041,40 +4056,37 @@
               <a:lnSpc>
                 <a:spcPct val="130000"/>
               </a:lnSpc>
-              <a:spcAft>
-                <a:spcPts val="400"/>
-              </a:spcAft>
             </a:pPr>
             <a:r>
-              <a:rPr sz="1000" b="0">
+              <a:rPr sz="950" b="0" i="0">
                 <a:solidFill>
                   <a:srgbClr val="5C6975"/>
                 </a:solidFill>
                 <a:latin typeface="Consolas"/>
               </a:rPr>
-              <a:t>Shieh, JAMA Oncol 2026 · Esserman (WISDOM), JAMA 2025 · Yala (Mirai), Sci Transl Med 2021 · Clairity FDA De Novo 2025</a:t>
+              <a:t>Shieh, JAMA Oncol 2026 · Esserman (WISDOM), JAMA 2025 · Yala (Mirai), Sci Transl Med 2021 · Clairity FDA 2025</a:t>
             </a:r>
           </a:p>
         </p:txBody>
       </p:sp>
       <p:pic>
         <p:nvPicPr>
-          <p:cNvPr id="7" name="Picture 6" descr="s_a406efe943.png"/>
+          <p:cNvPr id="8" name="Picture 7" descr="svg_950199d577.png"/>
           <p:cNvPicPr>
             <a:picLocks noChangeAspect="1"/>
           </p:cNvPicPr>
           <p:nvPr/>
         </p:nvPicPr>
         <p:blipFill>
-          <a:blip r:embed="rId3"/>
+          <a:blip r:embed="rId4"/>
           <a:stretch>
             <a:fillRect/>
           </a:stretch>
         </p:blipFill>
         <p:spPr>
           <a:xfrm>
-            <a:off x="6995160" y="1241658"/>
-            <a:ext cx="4617720" cy="4374682"/>
+            <a:off x="6949440" y="1313848"/>
+            <a:ext cx="4754880" cy="4504623"/>
           </a:xfrm>
           <a:prstGeom prst="rect">
             <a:avLst/>
@@ -4107,16 +4119,40 @@
         <p:nvPr/>
       </p:nvGrpSpPr>
       <p:grpSpPr/>
-      <p:sp>
-        <p:nvSpPr>
-          <p:cNvPr id="2" name="Rectangle 1"/>
+      <p:pic>
+        <p:nvPicPr>
+          <p:cNvPr id="2" name="Picture 1" descr="bg_motif.png"/>
+          <p:cNvPicPr>
+            <a:picLocks noChangeAspect="1"/>
+          </p:cNvPicPr>
+          <p:nvPr/>
+        </p:nvPicPr>
+        <p:blipFill>
+          <a:blip r:embed="rId2"/>
+          <a:stretch>
+            <a:fillRect/>
+          </a:stretch>
+        </p:blipFill>
+        <p:spPr>
+          <a:xfrm>
+            <a:off x="0" y="0"/>
+            <a:ext cx="12191695" cy="6858000"/>
+          </a:xfrm>
+          <a:prstGeom prst="rect">
+            <a:avLst/>
+          </a:prstGeom>
+        </p:spPr>
+      </p:pic>
+      <p:sp>
+        <p:nvSpPr>
+          <p:cNvPr id="3" name="Rectangle 2"/>
           <p:cNvSpPr/>
           <p:nvPr/>
         </p:nvSpPr>
         <p:spPr>
           <a:xfrm>
             <a:off x="0" y="0"/>
-            <a:ext cx="12191695" cy="38100"/>
+            <a:ext cx="5486400" cy="38100"/>
           </a:xfrm>
           <a:prstGeom prst="rect">
             <a:avLst/>
@@ -4153,14 +4189,14 @@
       </p:sp>
       <p:sp>
         <p:nvSpPr>
-          <p:cNvPr id="3" name="TextBox 2"/>
+          <p:cNvPr id="4" name="TextBox 3"/>
           <p:cNvSpPr txBox="1"/>
           <p:nvPr/>
         </p:nvSpPr>
         <p:spPr>
           <a:xfrm>
-            <a:off x="777240" y="411480"/>
-            <a:ext cx="8686800" cy="365760"/>
+            <a:off x="777240" y="502920"/>
+            <a:ext cx="8229600" cy="320040"/>
           </a:xfrm>
           <a:prstGeom prst="rect">
             <a:avLst/>
@@ -4168,21 +4204,18 @@
           <a:noFill/>
         </p:spPr>
         <p:txBody>
-          <a:bodyPr wrap="square" lIns="25400" rIns="25400" tIns="12700" bIns="12700">
-            <a:noAutofit/>
+          <a:bodyPr wrap="square" anchor="t" lIns="0" rIns="0" tIns="0" bIns="0">
+            <a:spAutoFit/>
           </a:bodyPr>
           <a:lstStyle/>
           <a:p>
             <a:pPr algn="l">
               <a:lnSpc>
-                <a:spcPct val="128000"/>
+                <a:spcPct val="100000"/>
               </a:lnSpc>
-              <a:spcAft>
-                <a:spcPts val="400"/>
-              </a:spcAft>
             </a:pPr>
             <a:r>
-              <a:rPr sz="1100" b="1">
+              <a:rPr sz="1100" b="1" i="0">
                 <a:solidFill>
                   <a:srgbClr val="E7AC51"/>
                 </a:solidFill>
@@ -4195,14 +4228,14 @@
       </p:sp>
       <p:sp>
         <p:nvSpPr>
-          <p:cNvPr id="4" name="TextBox 3"/>
+          <p:cNvPr id="5" name="TextBox 4"/>
           <p:cNvSpPr txBox="1"/>
           <p:nvPr/>
         </p:nvSpPr>
         <p:spPr>
           <a:xfrm>
-            <a:off x="777240" y="1217422"/>
-            <a:ext cx="5989320" cy="904240"/>
+            <a:off x="777240" y="1051560"/>
+            <a:ext cx="5943600" cy="1371600"/>
           </a:xfrm>
           <a:prstGeom prst="rect">
             <a:avLst/>
@@ -4210,21 +4243,18 @@
           <a:noFill/>
         </p:spPr>
         <p:txBody>
-          <a:bodyPr wrap="square" lIns="25400" rIns="25400" tIns="12700" bIns="12700">
-            <a:noAutofit/>
+          <a:bodyPr wrap="square" anchor="t" lIns="0" rIns="0" tIns="0" bIns="0">
+            <a:spAutoFit/>
           </a:bodyPr>
           <a:lstStyle/>
           <a:p>
             <a:pPr algn="l">
               <a:lnSpc>
-                <a:spcPct val="106000"/>
+                <a:spcPct val="112000"/>
               </a:lnSpc>
-              <a:spcAft>
-                <a:spcPts val="400"/>
-              </a:spcAft>
             </a:pPr>
             <a:r>
-              <a:rPr sz="2600" b="0">
+              <a:rPr sz="2700" b="1" i="0">
                 <a:solidFill>
                   <a:srgbClr val="ECEFF3"/>
                 </a:solidFill>
@@ -4233,7 +4263,7 @@
               <a:t>The second reader is now </a:t>
             </a:r>
             <a:r>
-              <a:rPr sz="2600" b="0">
+              <a:rPr sz="2700" b="1" i="0">
                 <a:solidFill>
                   <a:srgbClr val="E7AC51"/>
                 </a:solidFill>
@@ -4246,14 +4276,14 @@
       </p:sp>
       <p:sp>
         <p:nvSpPr>
-          <p:cNvPr id="5" name="TextBox 4"/>
+          <p:cNvPr id="6" name="TextBox 5"/>
           <p:cNvSpPr txBox="1"/>
           <p:nvPr/>
         </p:nvSpPr>
         <p:spPr>
           <a:xfrm>
-            <a:off x="777240" y="2121662"/>
-            <a:ext cx="5989320" cy="1029208"/>
+            <a:off x="777240" y="2286000"/>
+            <a:ext cx="5943600" cy="1554480"/>
           </a:xfrm>
           <a:prstGeom prst="rect">
             <a:avLst/>
@@ -4261,21 +4291,18 @@
           <a:noFill/>
         </p:spPr>
         <p:txBody>
-          <a:bodyPr wrap="square" lIns="25400" rIns="25400" tIns="12700" bIns="12700">
-            <a:noAutofit/>
+          <a:bodyPr wrap="square" anchor="t" lIns="0" rIns="0" tIns="0" bIns="0">
+            <a:spAutoFit/>
           </a:bodyPr>
           <a:lstStyle/>
           <a:p>
             <a:pPr algn="l">
               <a:lnSpc>
-                <a:spcPct val="128000"/>
+                <a:spcPct val="140000"/>
               </a:lnSpc>
-              <a:spcAft>
-                <a:spcPts val="400"/>
-              </a:spcAft>
             </a:pPr>
             <a:r>
-              <a:rPr sz="1400" b="0">
+              <a:rPr sz="1400" b="0" i="0">
                 <a:solidFill>
                   <a:srgbClr val="9DA9B5"/>
                 </a:solidFill>
@@ -4284,7 +4311,7 @@
               <a:t>Double reading has been replaced — not by one study, but by </a:t>
             </a:r>
             <a:r>
-              <a:rPr sz="1400" b="1">
+              <a:rPr sz="1400" b="1" i="0">
                 <a:solidFill>
                   <a:srgbClr val="ECEFF3"/>
                 </a:solidFill>
@@ -4293,7 +4320,7 @@
               <a:t>convergent RCT evidence across four continents</a:t>
             </a:r>
             <a:r>
-              <a:rPr sz="1400" b="0">
+              <a:rPr sz="1400" b="0" i="0">
                 <a:solidFill>
                   <a:srgbClr val="9DA9B5"/>
                 </a:solidFill>
@@ -4306,14 +4333,14 @@
       </p:sp>
       <p:sp>
         <p:nvSpPr>
-          <p:cNvPr id="6" name="TextBox 5"/>
+          <p:cNvPr id="7" name="TextBox 6"/>
           <p:cNvSpPr txBox="1"/>
           <p:nvPr/>
         </p:nvSpPr>
         <p:spPr>
           <a:xfrm>
-            <a:off x="777240" y="3150870"/>
-            <a:ext cx="5989320" cy="525780"/>
+            <a:off x="777240" y="3794760"/>
+            <a:ext cx="5760720" cy="457200"/>
           </a:xfrm>
           <a:prstGeom prst="rect">
             <a:avLst/>
@@ -4321,21 +4348,18 @@
           <a:noFill/>
         </p:spPr>
         <p:txBody>
-          <a:bodyPr wrap="square" lIns="25400" rIns="25400" tIns="12700" bIns="12700">
-            <a:noAutofit/>
+          <a:bodyPr wrap="square" anchor="t" lIns="0" rIns="0" tIns="0" bIns="0">
+            <a:spAutoFit/>
           </a:bodyPr>
           <a:lstStyle/>
           <a:p>
             <a:pPr algn="l">
               <a:lnSpc>
-                <a:spcPct val="112000"/>
+                <a:spcPct val="100000"/>
               </a:lnSpc>
-              <a:spcAft>
-                <a:spcPts val="400"/>
-              </a:spcAft>
             </a:pPr>
             <a:r>
-              <a:rPr sz="3000" b="0">
+              <a:rPr sz="2600" b="1" i="0">
                 <a:solidFill>
                   <a:srgbClr val="E7AC51"/>
                 </a:solidFill>
@@ -4348,14 +4372,14 @@
       </p:sp>
       <p:sp>
         <p:nvSpPr>
-          <p:cNvPr id="7" name="TextBox 6"/>
+          <p:cNvPr id="8" name="TextBox 7"/>
           <p:cNvSpPr txBox="1"/>
           <p:nvPr/>
         </p:nvSpPr>
         <p:spPr>
           <a:xfrm>
-            <a:off x="777240" y="3676650"/>
-            <a:ext cx="5989320" cy="346456"/>
+            <a:off x="777240" y="4215384"/>
+            <a:ext cx="5760720" cy="457200"/>
           </a:xfrm>
           <a:prstGeom prst="rect">
             <a:avLst/>
@@ -4363,25 +4387,22 @@
           <a:noFill/>
         </p:spPr>
         <p:txBody>
-          <a:bodyPr wrap="square" lIns="25400" rIns="25400" tIns="12700" bIns="12700">
-            <a:noAutofit/>
+          <a:bodyPr wrap="square" anchor="t" lIns="0" rIns="0" tIns="0" bIns="0">
+            <a:spAutoFit/>
           </a:bodyPr>
           <a:lstStyle/>
           <a:p>
             <a:pPr algn="l">
               <a:lnSpc>
-                <a:spcPct val="128000"/>
+                <a:spcPct val="120000"/>
               </a:lnSpc>
-              <a:spcAft>
-                <a:spcPts val="400"/>
-              </a:spcAft>
             </a:pPr>
             <a:r>
-              <a:rPr sz="1400" b="0">
+              <a:rPr sz="1100" b="0" i="0">
                 <a:solidFill>
                   <a:srgbClr val="9DA9B5"/>
                 </a:solidFill>
-                <a:latin typeface="Arial"/>
+                <a:latin typeface="Consolas"/>
               </a:rPr>
               <a:t>workload / cancers detected — MASAI (Lancet 2026)</a:t>
             </a:r>
@@ -4390,14 +4411,14 @@
       </p:sp>
       <p:sp>
         <p:nvSpPr>
-          <p:cNvPr id="8" name="TextBox 7"/>
+          <p:cNvPr id="9" name="TextBox 8"/>
           <p:cNvSpPr txBox="1"/>
           <p:nvPr/>
         </p:nvSpPr>
         <p:spPr>
           <a:xfrm>
-            <a:off x="777240" y="4023106"/>
-            <a:ext cx="5989320" cy="525780"/>
+            <a:off x="777240" y="4526280"/>
+            <a:ext cx="5760720" cy="457200"/>
           </a:xfrm>
           <a:prstGeom prst="rect">
             <a:avLst/>
@@ -4405,21 +4426,18 @@
           <a:noFill/>
         </p:spPr>
         <p:txBody>
-          <a:bodyPr wrap="square" lIns="25400" rIns="25400" tIns="12700" bIns="12700">
-            <a:noAutofit/>
+          <a:bodyPr wrap="square" anchor="t" lIns="0" rIns="0" tIns="0" bIns="0">
+            <a:spAutoFit/>
           </a:bodyPr>
           <a:lstStyle/>
           <a:p>
             <a:pPr algn="l">
               <a:lnSpc>
-                <a:spcPct val="112000"/>
+                <a:spcPct val="100000"/>
               </a:lnSpc>
-              <a:spcAft>
-                <a:spcPts val="400"/>
-              </a:spcAft>
             </a:pPr>
             <a:r>
-              <a:rPr sz="3000" b="0">
+              <a:rPr sz="2600" b="1" i="0">
                 <a:solidFill>
                   <a:srgbClr val="E7AC51"/>
                 </a:solidFill>
@@ -4432,14 +4450,14 @@
       </p:sp>
       <p:sp>
         <p:nvSpPr>
-          <p:cNvPr id="9" name="TextBox 8"/>
+          <p:cNvPr id="10" name="TextBox 9"/>
           <p:cNvSpPr txBox="1"/>
           <p:nvPr/>
         </p:nvSpPr>
         <p:spPr>
           <a:xfrm>
-            <a:off x="777240" y="4548886"/>
-            <a:ext cx="5989320" cy="346456"/>
+            <a:off x="777240" y="4946904"/>
+            <a:ext cx="5760720" cy="457200"/>
           </a:xfrm>
           <a:prstGeom prst="rect">
             <a:avLst/>
@@ -4447,25 +4465,22 @@
           <a:noFill/>
         </p:spPr>
         <p:txBody>
-          <a:bodyPr wrap="square" lIns="25400" rIns="25400" tIns="12700" bIns="12700">
-            <a:noAutofit/>
+          <a:bodyPr wrap="square" anchor="t" lIns="0" rIns="0" tIns="0" bIns="0">
+            <a:spAutoFit/>
           </a:bodyPr>
           <a:lstStyle/>
           <a:p>
             <a:pPr algn="l">
               <a:lnSpc>
-                <a:spcPct val="128000"/>
+                <a:spcPct val="120000"/>
               </a:lnSpc>
-              <a:spcAft>
-                <a:spcPts val="400"/>
-              </a:spcAft>
             </a:pPr>
             <a:r>
-              <a:rPr sz="1400" b="0">
+              <a:rPr sz="1100" b="0" i="0">
                 <a:solidFill>
                   <a:srgbClr val="9DA9B5"/>
                 </a:solidFill>
-                <a:latin typeface="Arial"/>
+                <a:latin typeface="Consolas"/>
               </a:rPr>
               <a:t>radiologist workload — Elías-Cabot (Nat Med 2026)</a:t>
             </a:r>
@@ -4474,14 +4489,14 @@
       </p:sp>
       <p:sp>
         <p:nvSpPr>
-          <p:cNvPr id="10" name="TextBox 9"/>
+          <p:cNvPr id="11" name="TextBox 10"/>
           <p:cNvSpPr txBox="1"/>
           <p:nvPr/>
         </p:nvSpPr>
         <p:spPr>
           <a:xfrm>
-            <a:off x="777240" y="4895342"/>
-            <a:ext cx="5989320" cy="525780"/>
+            <a:off x="777240" y="5257800"/>
+            <a:ext cx="5760720" cy="457200"/>
           </a:xfrm>
           <a:prstGeom prst="rect">
             <a:avLst/>
@@ -4489,21 +4504,18 @@
           <a:noFill/>
         </p:spPr>
         <p:txBody>
-          <a:bodyPr wrap="square" lIns="25400" rIns="25400" tIns="12700" bIns="12700">
-            <a:noAutofit/>
+          <a:bodyPr wrap="square" anchor="t" lIns="0" rIns="0" tIns="0" bIns="0">
+            <a:spAutoFit/>
           </a:bodyPr>
           <a:lstStyle/>
           <a:p>
             <a:pPr algn="l">
               <a:lnSpc>
-                <a:spcPct val="112000"/>
+                <a:spcPct val="100000"/>
               </a:lnSpc>
-              <a:spcAft>
-                <a:spcPts val="400"/>
-              </a:spcAft>
             </a:pPr>
             <a:r>
-              <a:rPr sz="3000" b="0">
+              <a:rPr sz="2600" b="1" i="0">
                 <a:solidFill>
                   <a:srgbClr val="5FB7C9"/>
                 </a:solidFill>
@@ -4516,14 +4528,14 @@
       </p:sp>
       <p:sp>
         <p:nvSpPr>
-          <p:cNvPr id="11" name="TextBox 10"/>
+          <p:cNvPr id="12" name="TextBox 11"/>
           <p:cNvSpPr txBox="1"/>
           <p:nvPr/>
         </p:nvSpPr>
         <p:spPr>
           <a:xfrm>
-            <a:off x="777240" y="5421122"/>
-            <a:ext cx="5989320" cy="346456"/>
+            <a:off x="777240" y="5678424"/>
+            <a:ext cx="5760720" cy="457200"/>
           </a:xfrm>
           <a:prstGeom prst="rect">
             <a:avLst/>
@@ -4531,25 +4543,22 @@
           <a:noFill/>
         </p:spPr>
         <p:txBody>
-          <a:bodyPr wrap="square" lIns="25400" rIns="25400" tIns="12700" bIns="12700">
-            <a:noAutofit/>
+          <a:bodyPr wrap="square" anchor="t" lIns="0" rIns="0" tIns="0" bIns="0">
+            <a:spAutoFit/>
           </a:bodyPr>
           <a:lstStyle/>
           <a:p>
             <a:pPr algn="l">
               <a:lnSpc>
-                <a:spcPct val="128000"/>
+                <a:spcPct val="120000"/>
               </a:lnSpc>
-              <a:spcAft>
-                <a:spcPts val="400"/>
-              </a:spcAft>
             </a:pPr>
             <a:r>
-              <a:rPr sz="1400" b="0">
+              <a:rPr sz="1100" b="0" i="0">
                 <a:solidFill>
                   <a:srgbClr val="9DA9B5"/>
                 </a:solidFill>
-                <a:latin typeface="Arial"/>
+                <a:latin typeface="Consolas"/>
               </a:rPr>
               <a:t>NPV of AI-normal triage at ~6/1,000 prevalence</a:t>
             </a:r>
@@ -4558,14 +4567,14 @@
       </p:sp>
       <p:sp>
         <p:nvSpPr>
-          <p:cNvPr id="12" name="TextBox 11"/>
+          <p:cNvPr id="13" name="TextBox 12"/>
           <p:cNvSpPr txBox="1"/>
           <p:nvPr/>
         </p:nvSpPr>
         <p:spPr>
           <a:xfrm>
-            <a:off x="777240" y="5767578"/>
-            <a:ext cx="5989320" cy="421640"/>
+            <a:off x="777240" y="6126480"/>
+            <a:ext cx="5943600" cy="548640"/>
           </a:xfrm>
           <a:prstGeom prst="rect">
             <a:avLst/>
@@ -4573,8 +4582,8 @@
           <a:noFill/>
         </p:spPr>
         <p:txBody>
-          <a:bodyPr wrap="square" lIns="25400" rIns="25400" tIns="12700" bIns="12700">
-            <a:noAutofit/>
+          <a:bodyPr wrap="square" anchor="t" lIns="0" rIns="0" tIns="0" bIns="0">
+            <a:spAutoFit/>
           </a:bodyPr>
           <a:lstStyle/>
           <a:p>
@@ -4582,12 +4591,9 @@
               <a:lnSpc>
                 <a:spcPct val="130000"/>
               </a:lnSpc>
-              <a:spcAft>
-                <a:spcPts val="400"/>
-              </a:spcAft>
             </a:pPr>
             <a:r>
-              <a:rPr sz="1000" b="0">
+              <a:rPr sz="950" b="0" i="0">
                 <a:solidFill>
                   <a:srgbClr val="5C6975"/>
                 </a:solidFill>
@@ -4600,22 +4606,22 @@
       </p:sp>
       <p:pic>
         <p:nvPicPr>
-          <p:cNvPr id="13" name="Picture 12" descr="s_54c4812462.png"/>
+          <p:cNvPr id="14" name="Picture 13" descr="svg_2a9344b0e8.png"/>
           <p:cNvPicPr>
             <a:picLocks noChangeAspect="1"/>
           </p:cNvPicPr>
           <p:nvPr/>
         </p:nvPicPr>
         <p:blipFill>
-          <a:blip r:embed="rId3"/>
+          <a:blip r:embed="rId4"/>
           <a:stretch>
             <a:fillRect/>
           </a:stretch>
         </p:blipFill>
         <p:spPr>
           <a:xfrm>
-            <a:off x="6995160" y="1484696"/>
-            <a:ext cx="4617720" cy="3888606"/>
+            <a:off x="6949440" y="1564105"/>
+            <a:ext cx="4754880" cy="4004109"/>
           </a:xfrm>
           <a:prstGeom prst="rect">
             <a:avLst/>
@@ -4648,16 +4654,40 @@
         <p:nvPr/>
       </p:nvGrpSpPr>
       <p:grpSpPr/>
-      <p:sp>
-        <p:nvSpPr>
-          <p:cNvPr id="2" name="Rectangle 1"/>
+      <p:pic>
+        <p:nvPicPr>
+          <p:cNvPr id="2" name="Picture 1" descr="bg_motif.png"/>
+          <p:cNvPicPr>
+            <a:picLocks noChangeAspect="1"/>
+          </p:cNvPicPr>
+          <p:nvPr/>
+        </p:nvPicPr>
+        <p:blipFill>
+          <a:blip r:embed="rId2"/>
+          <a:stretch>
+            <a:fillRect/>
+          </a:stretch>
+        </p:blipFill>
+        <p:spPr>
+          <a:xfrm>
+            <a:off x="0" y="0"/>
+            <a:ext cx="12191695" cy="6858000"/>
+          </a:xfrm>
+          <a:prstGeom prst="rect">
+            <a:avLst/>
+          </a:prstGeom>
+        </p:spPr>
+      </p:pic>
+      <p:sp>
+        <p:nvSpPr>
+          <p:cNvPr id="3" name="Rectangle 2"/>
           <p:cNvSpPr/>
           <p:nvPr/>
         </p:nvSpPr>
         <p:spPr>
           <a:xfrm>
             <a:off x="0" y="0"/>
-            <a:ext cx="12191695" cy="38100"/>
+            <a:ext cx="5486400" cy="38100"/>
           </a:xfrm>
           <a:prstGeom prst="rect">
             <a:avLst/>
@@ -4694,14 +4724,14 @@
       </p:sp>
       <p:sp>
         <p:nvSpPr>
-          <p:cNvPr id="3" name="TextBox 2"/>
+          <p:cNvPr id="4" name="TextBox 3"/>
           <p:cNvSpPr txBox="1"/>
           <p:nvPr/>
         </p:nvSpPr>
         <p:spPr>
           <a:xfrm>
-            <a:off x="777240" y="411480"/>
-            <a:ext cx="8686800" cy="365760"/>
+            <a:off x="777240" y="502920"/>
+            <a:ext cx="8229600" cy="320040"/>
           </a:xfrm>
           <a:prstGeom prst="rect">
             <a:avLst/>
@@ -4709,21 +4739,18 @@
           <a:noFill/>
         </p:spPr>
         <p:txBody>
-          <a:bodyPr wrap="square" lIns="25400" rIns="25400" tIns="12700" bIns="12700">
-            <a:noAutofit/>
+          <a:bodyPr wrap="square" anchor="t" lIns="0" rIns="0" tIns="0" bIns="0">
+            <a:spAutoFit/>
           </a:bodyPr>
           <a:lstStyle/>
           <a:p>
             <a:pPr algn="l">
               <a:lnSpc>
-                <a:spcPct val="128000"/>
+                <a:spcPct val="100000"/>
               </a:lnSpc>
-              <a:spcAft>
-                <a:spcPts val="400"/>
-              </a:spcAft>
             </a:pPr>
             <a:r>
-              <a:rPr sz="1100" b="1">
+              <a:rPr sz="1100" b="1" i="0">
                 <a:solidFill>
                   <a:srgbClr val="E7AC51"/>
                 </a:solidFill>
@@ -4736,14 +4763,14 @@
       </p:sp>
       <p:sp>
         <p:nvSpPr>
-          <p:cNvPr id="4" name="TextBox 3"/>
+          <p:cNvPr id="5" name="TextBox 4"/>
           <p:cNvSpPr txBox="1"/>
           <p:nvPr/>
         </p:nvSpPr>
         <p:spPr>
           <a:xfrm>
-            <a:off x="777240" y="1738375"/>
-            <a:ext cx="5989320" cy="1643888"/>
+            <a:off x="777240" y="914400"/>
+            <a:ext cx="10789920" cy="1371600"/>
           </a:xfrm>
           <a:prstGeom prst="rect">
             <a:avLst/>
@@ -4751,21 +4778,18 @@
           <a:noFill/>
         </p:spPr>
         <p:txBody>
-          <a:bodyPr wrap="square" lIns="25400" rIns="25400" tIns="12700" bIns="12700">
-            <a:noAutofit/>
+          <a:bodyPr wrap="square" anchor="t" lIns="0" rIns="0" tIns="0" bIns="0">
+            <a:spAutoFit/>
           </a:bodyPr>
           <a:lstStyle/>
           <a:p>
             <a:pPr algn="l">
               <a:lnSpc>
-                <a:spcPct val="106000"/>
+                <a:spcPct val="112000"/>
               </a:lnSpc>
-              <a:spcAft>
-                <a:spcPts val="400"/>
-              </a:spcAft>
             </a:pPr>
             <a:r>
-              <a:rPr sz="2600" b="0">
+              <a:rPr sz="2200" b="1" i="0">
                 <a:solidFill>
                   <a:srgbClr val="ECEFF3"/>
                 </a:solidFill>
@@ -4774,7 +4798,7 @@
               <a:t>From one score to a multimodal </a:t>
             </a:r>
             <a:r>
-              <a:rPr sz="2600" b="0">
+              <a:rPr sz="2200" b="1" i="0">
                 <a:solidFill>
                   <a:srgbClr val="E7AC51"/>
                 </a:solidFill>
@@ -4787,14 +4811,14 @@
       </p:sp>
       <p:sp>
         <p:nvSpPr>
-          <p:cNvPr id="5" name="TextBox 4"/>
+          <p:cNvPr id="6" name="TextBox 5"/>
           <p:cNvSpPr txBox="1"/>
           <p:nvPr/>
         </p:nvSpPr>
         <p:spPr>
           <a:xfrm>
-            <a:off x="777240" y="3382264"/>
-            <a:ext cx="5989320" cy="801623"/>
+            <a:off x="777240" y="1783080"/>
+            <a:ext cx="10789920" cy="731520"/>
           </a:xfrm>
           <a:prstGeom prst="rect">
             <a:avLst/>
@@ -4802,21 +4826,18 @@
           <a:noFill/>
         </p:spPr>
         <p:txBody>
-          <a:bodyPr wrap="square" lIns="25400" rIns="25400" tIns="12700" bIns="12700">
-            <a:noAutofit/>
+          <a:bodyPr wrap="square" anchor="t" lIns="0" rIns="0" tIns="0" bIns="0">
+            <a:spAutoFit/>
           </a:bodyPr>
           <a:lstStyle/>
           <a:p>
             <a:pPr algn="l">
               <a:lnSpc>
-                <a:spcPct val="128000"/>
+                <a:spcPct val="135000"/>
               </a:lnSpc>
-              <a:spcAft>
-                <a:spcPts val="400"/>
-              </a:spcAft>
             </a:pPr>
             <a:r>
-              <a:rPr sz="1400" b="0">
+              <a:rPr sz="1300" b="0" i="0">
                 <a:solidFill>
                   <a:srgbClr val="9DA9B5"/>
                 </a:solidFill>
@@ -4825,7 +4846,7 @@
               <a:t>Each layer's 2025 evidence, and where 2035 takes it — </a:t>
             </a:r>
             <a:r>
-              <a:rPr sz="1400" b="1">
+              <a:rPr sz="1300" b="1" i="0">
                 <a:solidFill>
                   <a:srgbClr val="ECEFF3"/>
                 </a:solidFill>
@@ -4836,99 +4857,69 @@
           </a:p>
         </p:txBody>
       </p:sp>
-      <p:sp>
-        <p:nvSpPr>
-          <p:cNvPr id="6" name="TextBox 5"/>
-          <p:cNvSpPr txBox="1"/>
-          <p:nvPr/>
-        </p:nvSpPr>
-        <p:spPr>
-          <a:xfrm>
-            <a:off x="777240" y="4183888"/>
-            <a:ext cx="5989320" cy="1484375"/>
-          </a:xfrm>
-          <a:prstGeom prst="rect">
-            <a:avLst/>
-          </a:prstGeom>
-          <a:noFill/>
-        </p:spPr>
-        <p:txBody>
-          <a:bodyPr wrap="square" lIns="25400" rIns="25400" tIns="12700" bIns="12700">
-            <a:noAutofit/>
-          </a:bodyPr>
-          <a:lstStyle/>
-          <a:p>
-            <a:pPr algn="l">
-              <a:lnSpc>
-                <a:spcPct val="128000"/>
-              </a:lnSpc>
-              <a:spcAft>
-                <a:spcPts val="400"/>
-              </a:spcAft>
-            </a:pPr>
-            <a:r>
-              <a:rPr sz="1400" b="1">
-                <a:solidFill>
-                  <a:srgbClr val="ECEFF3"/>
-                </a:solidFill>
-                <a:latin typeface="Arial"/>
-              </a:rPr>
-              <a:t>Now (2025):</a:t>
-            </a:r>
-            <a:r>
-              <a:rPr sz="1400" b="0">
-                <a:solidFill>
-                  <a:srgbClr val="9DA9B5"/>
-                </a:solidFill>
-                <a:latin typeface="Arial"/>
-              </a:rPr>
-              <a:t> the evidence shown → </a:t>
-            </a:r>
-            <a:r>
-              <a:rPr sz="1400" b="1">
-                <a:solidFill>
-                  <a:srgbClr val="ECEFF3"/>
-                </a:solidFill>
-                <a:latin typeface="Arial"/>
-              </a:rPr>
-              <a:t>2035:</a:t>
-            </a:r>
-            <a:r>
-              <a:rPr sz="1400" b="0">
-                <a:solidFill>
-                  <a:srgbClr val="9DA9B5"/>
-                </a:solidFill>
-                <a:latin typeface="Arial"/>
-              </a:rPr>
-              <a:t> one unified model gates acquisition and emits detection + recurrence + treatment. MASAI (Lancet 2026) · PRAIM (Nat Med 2025) · ScreenTrustMRI (Nat Med 2024) · BMU-Net (Nat Biomed Eng 2024) · UNI (Nat Med 2024) · BINDS (Nat Biomed Eng 2026) · ctDNA MRD (Ann Oncol 2025).</a:t>
-            </a:r>
-          </a:p>
-        </p:txBody>
-      </p:sp>
       <p:pic>
         <p:nvPicPr>
-          <p:cNvPr id="7" name="Picture 6" descr="s_044a31649b.png"/>
+          <p:cNvPr id="7" name="Picture 6" descr="svg_cd321524ea.png"/>
           <p:cNvPicPr>
             <a:picLocks noChangeAspect="1"/>
           </p:cNvPicPr>
           <p:nvPr/>
         </p:nvPicPr>
         <p:blipFill>
-          <a:blip r:embed="rId3"/>
+          <a:blip r:embed="rId4"/>
           <a:stretch>
             <a:fillRect/>
           </a:stretch>
         </p:blipFill>
         <p:spPr>
           <a:xfrm>
-            <a:off x="6995160" y="2385395"/>
-            <a:ext cx="4617720" cy="2087209"/>
+            <a:off x="2439344" y="2514600"/>
+            <a:ext cx="7282831" cy="3291840"/>
           </a:xfrm>
           <a:prstGeom prst="rect">
             <a:avLst/>
           </a:prstGeom>
         </p:spPr>
       </p:pic>
+      <p:sp>
+        <p:nvSpPr>
+          <p:cNvPr id="8" name="TextBox 7"/>
+          <p:cNvSpPr txBox="1"/>
+          <p:nvPr/>
+        </p:nvSpPr>
+        <p:spPr>
+          <a:xfrm>
+            <a:off x="777240" y="5989320"/>
+            <a:ext cx="10789920" cy="548640"/>
+          </a:xfrm>
+          <a:prstGeom prst="rect">
+            <a:avLst/>
+          </a:prstGeom>
+          <a:noFill/>
+        </p:spPr>
+        <p:txBody>
+          <a:bodyPr wrap="square" anchor="t" lIns="0" rIns="0" tIns="0" bIns="0">
+            <a:spAutoFit/>
+          </a:bodyPr>
+          <a:lstStyle/>
+          <a:p>
+            <a:pPr algn="l">
+              <a:lnSpc>
+                <a:spcPct val="130000"/>
+              </a:lnSpc>
+            </a:pPr>
+            <a:r>
+              <a:rPr sz="950" b="0" i="0">
+                <a:solidFill>
+                  <a:srgbClr val="5C6975"/>
+                </a:solidFill>
+                <a:latin typeface="Consolas"/>
+              </a:rPr>
+              <a:t>MASAI (Lancet 2026) · PRAIM (Nat Med 2025) · ScreenTrustMRI (Nat Med 2024) · BMU-Net · UNI · BINDS · ctDNA MRD.</a:t>
+            </a:r>
+          </a:p>
+        </p:txBody>
+      </p:sp>
     </p:spTree>
   </p:cSld>
   <p:clrMapOvr>
@@ -4955,16 +4946,40 @@
         <p:nvPr/>
       </p:nvGrpSpPr>
       <p:grpSpPr/>
-      <p:sp>
-        <p:nvSpPr>
-          <p:cNvPr id="2" name="Rectangle 1"/>
+      <p:pic>
+        <p:nvPicPr>
+          <p:cNvPr id="2" name="Picture 1" descr="bg_motif.png"/>
+          <p:cNvPicPr>
+            <a:picLocks noChangeAspect="1"/>
+          </p:cNvPicPr>
+          <p:nvPr/>
+        </p:nvPicPr>
+        <p:blipFill>
+          <a:blip r:embed="rId2"/>
+          <a:stretch>
+            <a:fillRect/>
+          </a:stretch>
+        </p:blipFill>
+        <p:spPr>
+          <a:xfrm>
+            <a:off x="0" y="0"/>
+            <a:ext cx="12191695" cy="6858000"/>
+          </a:xfrm>
+          <a:prstGeom prst="rect">
+            <a:avLst/>
+          </a:prstGeom>
+        </p:spPr>
+      </p:pic>
+      <p:sp>
+        <p:nvSpPr>
+          <p:cNvPr id="3" name="Rectangle 2"/>
           <p:cNvSpPr/>
           <p:nvPr/>
         </p:nvSpPr>
         <p:spPr>
           <a:xfrm>
             <a:off x="0" y="0"/>
-            <a:ext cx="12191695" cy="38100"/>
+            <a:ext cx="5486400" cy="38100"/>
           </a:xfrm>
           <a:prstGeom prst="rect">
             <a:avLst/>
@@ -5001,14 +5016,14 @@
       </p:sp>
       <p:sp>
         <p:nvSpPr>
-          <p:cNvPr id="3" name="TextBox 2"/>
+          <p:cNvPr id="4" name="TextBox 3"/>
           <p:cNvSpPr txBox="1"/>
           <p:nvPr/>
         </p:nvSpPr>
         <p:spPr>
           <a:xfrm>
-            <a:off x="777240" y="411480"/>
-            <a:ext cx="8686800" cy="365760"/>
+            <a:off x="777240" y="502920"/>
+            <a:ext cx="8229600" cy="320040"/>
           </a:xfrm>
           <a:prstGeom prst="rect">
             <a:avLst/>
@@ -5016,21 +5031,18 @@
           <a:noFill/>
         </p:spPr>
         <p:txBody>
-          <a:bodyPr wrap="square" lIns="25400" rIns="25400" tIns="12700" bIns="12700">
-            <a:noAutofit/>
+          <a:bodyPr wrap="square" anchor="t" lIns="0" rIns="0" tIns="0" bIns="0">
+            <a:spAutoFit/>
           </a:bodyPr>
           <a:lstStyle/>
           <a:p>
             <a:pPr algn="l">
               <a:lnSpc>
-                <a:spcPct val="128000"/>
+                <a:spcPct val="100000"/>
               </a:lnSpc>
-              <a:spcAft>
-                <a:spcPts val="400"/>
-              </a:spcAft>
             </a:pPr>
             <a:r>
-              <a:rPr sz="1100" b="1">
+              <a:rPr sz="1100" b="1" i="0">
                 <a:solidFill>
                   <a:srgbClr val="E7AC51"/>
                 </a:solidFill>
@@ -5043,14 +5055,14 @@
       </p:sp>
       <p:sp>
         <p:nvSpPr>
-          <p:cNvPr id="4" name="TextBox 3"/>
+          <p:cNvPr id="5" name="TextBox 4"/>
           <p:cNvSpPr txBox="1"/>
           <p:nvPr/>
         </p:nvSpPr>
         <p:spPr>
           <a:xfrm>
-            <a:off x="777240" y="1078992"/>
-            <a:ext cx="5989320" cy="904240"/>
+            <a:off x="777240" y="960120"/>
+            <a:ext cx="5943600" cy="1371600"/>
           </a:xfrm>
           <a:prstGeom prst="rect">
             <a:avLst/>
@@ -5058,21 +5070,18 @@
           <a:noFill/>
         </p:spPr>
         <p:txBody>
-          <a:bodyPr wrap="square" lIns="25400" rIns="25400" tIns="12700" bIns="12700">
-            <a:noAutofit/>
+          <a:bodyPr wrap="square" anchor="t" lIns="0" rIns="0" tIns="0" bIns="0">
+            <a:spAutoFit/>
           </a:bodyPr>
           <a:lstStyle/>
           <a:p>
             <a:pPr algn="l">
               <a:lnSpc>
-                <a:spcPct val="106000"/>
+                <a:spcPct val="112000"/>
               </a:lnSpc>
-              <a:spcAft>
-                <a:spcPts val="400"/>
-              </a:spcAft>
             </a:pPr>
             <a:r>
-              <a:rPr sz="2600" b="0">
+              <a:rPr sz="2600" b="1" i="0">
                 <a:solidFill>
                   <a:srgbClr val="ECEFF3"/>
                 </a:solidFill>
@@ -5081,7 +5090,7 @@
               <a:t>The mammogram is now a </a:t>
             </a:r>
             <a:r>
-              <a:rPr sz="2600" b="0">
+              <a:rPr sz="2600" b="1" i="0">
                 <a:solidFill>
                   <a:srgbClr val="E7AC51"/>
                 </a:solidFill>
@@ -5094,14 +5103,14 @@
       </p:sp>
       <p:sp>
         <p:nvSpPr>
-          <p:cNvPr id="5" name="TextBox 4"/>
+          <p:cNvPr id="6" name="TextBox 5"/>
           <p:cNvSpPr txBox="1"/>
           <p:nvPr/>
         </p:nvSpPr>
         <p:spPr>
           <a:xfrm>
-            <a:off x="777240" y="1983231"/>
-            <a:ext cx="5989320" cy="574040"/>
+            <a:off x="777240" y="2148840"/>
+            <a:ext cx="5943600" cy="914400"/>
           </a:xfrm>
           <a:prstGeom prst="rect">
             <a:avLst/>
@@ -5109,21 +5118,18 @@
           <a:noFill/>
         </p:spPr>
         <p:txBody>
-          <a:bodyPr wrap="square" lIns="25400" rIns="25400" tIns="12700" bIns="12700">
-            <a:noAutofit/>
+          <a:bodyPr wrap="square" anchor="t" lIns="0" rIns="0" tIns="0" bIns="0">
+            <a:spAutoFit/>
           </a:bodyPr>
           <a:lstStyle/>
           <a:p>
             <a:pPr algn="l">
               <a:lnSpc>
-                <a:spcPct val="128000"/>
+                <a:spcPct val="140000"/>
               </a:lnSpc>
-              <a:spcAft>
-                <a:spcPts val="400"/>
-              </a:spcAft>
             </a:pPr>
             <a:r>
-              <a:rPr sz="1400" b="0">
+              <a:rPr sz="1450" b="0" i="0">
                 <a:solidFill>
                   <a:srgbClr val="9DA9B5"/>
                 </a:solidFill>
@@ -5132,7 +5138,7 @@
               <a:t>We built a cancer screen and found a </a:t>
             </a:r>
             <a:r>
-              <a:rPr sz="1400" b="1">
+              <a:rPr sz="1450" b="1" i="0">
                 <a:solidFill>
                   <a:srgbClr val="ECEFF3"/>
                 </a:solidFill>
@@ -5141,7 +5147,7 @@
               <a:t>window into the entire body</a:t>
             </a:r>
             <a:r>
-              <a:rPr sz="1400" b="0">
+              <a:rPr sz="1450" b="0" i="0">
                 <a:solidFill>
                   <a:srgbClr val="9DA9B5"/>
                 </a:solidFill>
@@ -5154,14 +5160,14 @@
       </p:sp>
       <p:sp>
         <p:nvSpPr>
-          <p:cNvPr id="6" name="TextBox 5"/>
+          <p:cNvPr id="7" name="TextBox 6"/>
           <p:cNvSpPr txBox="1"/>
           <p:nvPr/>
         </p:nvSpPr>
         <p:spPr>
           <a:xfrm>
-            <a:off x="777240" y="2557272"/>
-            <a:ext cx="5989320" cy="525780"/>
+            <a:off x="777240" y="3063240"/>
+            <a:ext cx="5760720" cy="457200"/>
           </a:xfrm>
           <a:prstGeom prst="rect">
             <a:avLst/>
@@ -5169,21 +5175,18 @@
           <a:noFill/>
         </p:spPr>
         <p:txBody>
-          <a:bodyPr wrap="square" lIns="25400" rIns="25400" tIns="12700" bIns="12700">
-            <a:noAutofit/>
+          <a:bodyPr wrap="square" anchor="t" lIns="0" rIns="0" tIns="0" bIns="0">
+            <a:spAutoFit/>
           </a:bodyPr>
           <a:lstStyle/>
           <a:p>
             <a:pPr algn="l">
               <a:lnSpc>
-                <a:spcPct val="112000"/>
+                <a:spcPct val="100000"/>
               </a:lnSpc>
-              <a:spcAft>
-                <a:spcPts val="400"/>
-              </a:spcAft>
             </a:pPr>
             <a:r>
-              <a:rPr sz="3000" b="0">
+              <a:rPr sz="2600" b="1" i="0">
                 <a:solidFill>
                   <a:srgbClr val="E7AC51"/>
                 </a:solidFill>
@@ -5196,14 +5199,14 @@
       </p:sp>
       <p:sp>
         <p:nvSpPr>
-          <p:cNvPr id="7" name="TextBox 6"/>
+          <p:cNvPr id="8" name="TextBox 7"/>
           <p:cNvSpPr txBox="1"/>
           <p:nvPr/>
         </p:nvSpPr>
         <p:spPr>
           <a:xfrm>
-            <a:off x="777240" y="3083051"/>
-            <a:ext cx="5989320" cy="346456"/>
+            <a:off x="777240" y="3483864"/>
+            <a:ext cx="5760720" cy="457200"/>
           </a:xfrm>
           <a:prstGeom prst="rect">
             <a:avLst/>
@@ -5211,25 +5214,22 @@
           <a:noFill/>
         </p:spPr>
         <p:txBody>
-          <a:bodyPr wrap="square" lIns="25400" rIns="25400" tIns="12700" bIns="12700">
-            <a:noAutofit/>
+          <a:bodyPr wrap="square" anchor="t" lIns="0" rIns="0" tIns="0" bIns="0">
+            <a:spAutoFit/>
           </a:bodyPr>
           <a:lstStyle/>
           <a:p>
             <a:pPr algn="l">
               <a:lnSpc>
-                <a:spcPct val="128000"/>
+                <a:spcPct val="120000"/>
               </a:lnSpc>
-              <a:spcAft>
-                <a:spcPts val="400"/>
-              </a:spcAft>
             </a:pPr>
             <a:r>
-              <a:rPr sz="1400" b="0">
+              <a:rPr sz="1100" b="0" i="0">
                 <a:solidFill>
                   <a:srgbClr val="9DA9B5"/>
                 </a:solidFill>
-                <a:latin typeface="Arial"/>
+                <a:latin typeface="Consolas"/>
               </a:rPr>
               <a:t>5-yr mortality, severe BAC — 123,762 (Eur Heart J 2026)</a:t>
             </a:r>
@@ -5238,14 +5238,14 @@
       </p:sp>
       <p:sp>
         <p:nvSpPr>
-          <p:cNvPr id="8" name="TextBox 7"/>
+          <p:cNvPr id="9" name="TextBox 8"/>
           <p:cNvSpPr txBox="1"/>
           <p:nvPr/>
         </p:nvSpPr>
         <p:spPr>
           <a:xfrm>
-            <a:off x="777240" y="3429507"/>
-            <a:ext cx="5989320" cy="525780"/>
+            <a:off x="777240" y="3794760"/>
+            <a:ext cx="5760720" cy="457200"/>
           </a:xfrm>
           <a:prstGeom prst="rect">
             <a:avLst/>
@@ -5253,21 +5253,18 @@
           <a:noFill/>
         </p:spPr>
         <p:txBody>
-          <a:bodyPr wrap="square" lIns="25400" rIns="25400" tIns="12700" bIns="12700">
-            <a:noAutofit/>
+          <a:bodyPr wrap="square" anchor="t" lIns="0" rIns="0" tIns="0" bIns="0">
+            <a:spAutoFit/>
           </a:bodyPr>
           <a:lstStyle/>
           <a:p>
             <a:pPr algn="l">
               <a:lnSpc>
-                <a:spcPct val="112000"/>
+                <a:spcPct val="100000"/>
               </a:lnSpc>
-              <a:spcAft>
-                <a:spcPts val="400"/>
-              </a:spcAft>
             </a:pPr>
             <a:r>
-              <a:rPr sz="3000" b="0">
+              <a:rPr sz="2600" b="1" i="0">
                 <a:solidFill>
                   <a:srgbClr val="E7AC51"/>
                 </a:solidFill>
@@ -5280,14 +5277,14 @@
       </p:sp>
       <p:sp>
         <p:nvSpPr>
-          <p:cNvPr id="9" name="TextBox 8"/>
+          <p:cNvPr id="10" name="TextBox 9"/>
           <p:cNvSpPr txBox="1"/>
           <p:nvPr/>
         </p:nvSpPr>
         <p:spPr>
           <a:xfrm>
-            <a:off x="777240" y="3955287"/>
-            <a:ext cx="5989320" cy="346456"/>
+            <a:off x="777240" y="4215384"/>
+            <a:ext cx="5760720" cy="457200"/>
           </a:xfrm>
           <a:prstGeom prst="rect">
             <a:avLst/>
@@ -5295,25 +5292,22 @@
           <a:noFill/>
         </p:spPr>
         <p:txBody>
-          <a:bodyPr wrap="square" lIns="25400" rIns="25400" tIns="12700" bIns="12700">
-            <a:noAutofit/>
+          <a:bodyPr wrap="square" anchor="t" lIns="0" rIns="0" tIns="0" bIns="0">
+            <a:spAutoFit/>
           </a:bodyPr>
           <a:lstStyle/>
           <a:p>
             <a:pPr algn="l">
               <a:lnSpc>
-                <a:spcPct val="128000"/>
+                <a:spcPct val="120000"/>
               </a:lnSpc>
-              <a:spcAft>
-                <a:spcPts val="400"/>
-              </a:spcAft>
             </a:pPr>
             <a:r>
-              <a:rPr sz="1400" b="0">
+              <a:rPr sz="1100" b="0" i="0">
                 <a:solidFill>
                   <a:srgbClr val="9DA9B5"/>
                 </a:solidFill>
-                <a:latin typeface="Arial"/>
+                <a:latin typeface="Consolas"/>
               </a:rPr>
               <a:t>women: CVD from the image alone (Heart 2026)</a:t>
             </a:r>
@@ -5322,14 +5316,14 @@
       </p:sp>
       <p:sp>
         <p:nvSpPr>
-          <p:cNvPr id="10" name="TextBox 9"/>
+          <p:cNvPr id="11" name="TextBox 10"/>
           <p:cNvSpPr txBox="1"/>
           <p:nvPr/>
         </p:nvSpPr>
         <p:spPr>
           <a:xfrm>
-            <a:off x="777240" y="4301743"/>
-            <a:ext cx="5989320" cy="525780"/>
+            <a:off x="777240" y="4526280"/>
+            <a:ext cx="5760720" cy="457200"/>
           </a:xfrm>
           <a:prstGeom prst="rect">
             <a:avLst/>
@@ -5337,21 +5331,18 @@
           <a:noFill/>
         </p:spPr>
         <p:txBody>
-          <a:bodyPr wrap="square" lIns="25400" rIns="25400" tIns="12700" bIns="12700">
-            <a:noAutofit/>
+          <a:bodyPr wrap="square" anchor="t" lIns="0" rIns="0" tIns="0" bIns="0">
+            <a:spAutoFit/>
           </a:bodyPr>
           <a:lstStyle/>
           <a:p>
             <a:pPr algn="l">
               <a:lnSpc>
-                <a:spcPct val="112000"/>
+                <a:spcPct val="100000"/>
               </a:lnSpc>
-              <a:spcAft>
-                <a:spcPts val="400"/>
-              </a:spcAft>
             </a:pPr>
             <a:r>
-              <a:rPr sz="3000" b="0">
+              <a:rPr sz="2600" b="1" i="0">
                 <a:solidFill>
                   <a:srgbClr val="5FB7C9"/>
                 </a:solidFill>
@@ -5364,14 +5355,14 @@
       </p:sp>
       <p:sp>
         <p:nvSpPr>
-          <p:cNvPr id="11" name="TextBox 10"/>
+          <p:cNvPr id="12" name="TextBox 11"/>
           <p:cNvSpPr txBox="1"/>
           <p:nvPr/>
         </p:nvSpPr>
         <p:spPr>
           <a:xfrm>
-            <a:off x="777240" y="4827523"/>
-            <a:ext cx="5989320" cy="346456"/>
+            <a:off x="777240" y="4946904"/>
+            <a:ext cx="5760720" cy="457200"/>
           </a:xfrm>
           <a:prstGeom prst="rect">
             <a:avLst/>
@@ -5379,25 +5370,22 @@
           <a:noFill/>
         </p:spPr>
         <p:txBody>
-          <a:bodyPr wrap="square" lIns="25400" rIns="25400" tIns="12700" bIns="12700">
-            <a:noAutofit/>
+          <a:bodyPr wrap="square" anchor="t" lIns="0" rIns="0" tIns="0" bIns="0">
+            <a:spAutoFit/>
           </a:bodyPr>
           <a:lstStyle/>
           <a:p>
             <a:pPr algn="l">
               <a:lnSpc>
-                <a:spcPct val="128000"/>
+                <a:spcPct val="120000"/>
               </a:lnSpc>
-              <a:spcAft>
-                <a:spcPts val="400"/>
-              </a:spcAft>
             </a:pPr>
             <a:r>
-              <a:rPr sz="1400" b="0">
+              <a:rPr sz="1100" b="0" i="0">
                 <a:solidFill>
                   <a:srgbClr val="9DA9B5"/>
                 </a:solidFill>
-                <a:latin typeface="Arial"/>
+                <a:latin typeface="Consolas"/>
               </a:rPr>
               <a:t>from the mammogram, ±4–6 yr — Mammo-AGE</a:t>
             </a:r>
@@ -5406,14 +5394,14 @@
       </p:sp>
       <p:sp>
         <p:nvSpPr>
-          <p:cNvPr id="12" name="TextBox 11"/>
+          <p:cNvPr id="13" name="TextBox 12"/>
           <p:cNvSpPr txBox="1"/>
           <p:nvPr/>
         </p:nvSpPr>
         <p:spPr>
           <a:xfrm>
-            <a:off x="777240" y="5173979"/>
-            <a:ext cx="5989320" cy="801623"/>
+            <a:off x="777240" y="5349240"/>
+            <a:ext cx="5943600" cy="914400"/>
           </a:xfrm>
           <a:prstGeom prst="rect">
             <a:avLst/>
@@ -5421,21 +5409,18 @@
           <a:noFill/>
         </p:spPr>
         <p:txBody>
-          <a:bodyPr wrap="square" lIns="25400" rIns="25400" tIns="12700" bIns="12700">
-            <a:noAutofit/>
+          <a:bodyPr wrap="square" anchor="t" lIns="0" rIns="0" tIns="0" bIns="0">
+            <a:spAutoFit/>
           </a:bodyPr>
           <a:lstStyle/>
           <a:p>
             <a:pPr algn="l">
               <a:lnSpc>
-                <a:spcPct val="128000"/>
+                <a:spcPct val="135000"/>
               </a:lnSpc>
-              <a:spcAft>
-                <a:spcPts val="400"/>
-              </a:spcAft>
             </a:pPr>
             <a:r>
-              <a:rPr sz="1400" b="1">
+              <a:rPr sz="1250" b="1" i="0">
                 <a:solidFill>
                   <a:srgbClr val="ECEFF3"/>
                 </a:solidFill>
@@ -5444,7 +5429,7 @@
               <a:t>~40M US mammograms/yr</a:t>
             </a:r>
             <a:r>
-              <a:rPr sz="1400" b="0">
+              <a:rPr sz="1250" b="0" i="0">
                 <a:solidFill>
                   <a:srgbClr val="9DA9B5"/>
                 </a:solidFill>
@@ -5457,14 +5442,14 @@
       </p:sp>
       <p:sp>
         <p:nvSpPr>
-          <p:cNvPr id="13" name="TextBox 12"/>
+          <p:cNvPr id="14" name="TextBox 13"/>
           <p:cNvSpPr txBox="1"/>
           <p:nvPr/>
         </p:nvSpPr>
         <p:spPr>
           <a:xfrm>
-            <a:off x="777240" y="5975603"/>
-            <a:ext cx="5989320" cy="586740"/>
+            <a:off x="777240" y="6355080"/>
+            <a:ext cx="5943600" cy="548640"/>
           </a:xfrm>
           <a:prstGeom prst="rect">
             <a:avLst/>
@@ -5472,8 +5457,8 @@
           <a:noFill/>
         </p:spPr>
         <p:txBody>
-          <a:bodyPr wrap="square" lIns="25400" rIns="25400" tIns="12700" bIns="12700">
-            <a:noAutofit/>
+          <a:bodyPr wrap="square" anchor="t" lIns="0" rIns="0" tIns="0" bIns="0">
+            <a:spAutoFit/>
           </a:bodyPr>
           <a:lstStyle/>
           <a:p>
@@ -5481,40 +5466,37 @@
               <a:lnSpc>
                 <a:spcPct val="130000"/>
               </a:lnSpc>
-              <a:spcAft>
-                <a:spcPts val="400"/>
-              </a:spcAft>
             </a:pPr>
             <a:r>
-              <a:rPr sz="1000" b="0">
+              <a:rPr sz="950" b="0" i="0">
                 <a:solidFill>
                   <a:srgbClr val="5C6975"/>
                 </a:solidFill>
                 <a:latin typeface="Consolas"/>
               </a:rPr>
-              <a:t>Dapamede, Eur Heart J 2026 (our paper) · Barraclough, Heart 2026 · Pan (Mammo-AGE), Nat Commun 2025 · Pickhardt (CT), Nat Commun 2025 · RETFound, Nature 2023</a:t>
+              <a:t>Dapamede, Eur Heart J 2026 · Barraclough, Heart 2026 · Pan (Mammo-AGE), Nat Commun 2025 · RETFound, Nature 2023</a:t>
             </a:r>
           </a:p>
         </p:txBody>
       </p:sp>
       <p:pic>
         <p:nvPicPr>
-          <p:cNvPr id="14" name="Picture 13" descr="s_0bd242d089.png"/>
+          <p:cNvPr id="15" name="Picture 14" descr="svg_22340b3edb.png"/>
           <p:cNvPicPr>
             <a:picLocks noChangeAspect="1"/>
           </p:cNvPicPr>
           <p:nvPr/>
         </p:nvPicPr>
         <p:blipFill>
-          <a:blip r:embed="rId3"/>
+          <a:blip r:embed="rId4"/>
           <a:stretch>
             <a:fillRect/>
           </a:stretch>
         </p:blipFill>
         <p:spPr>
           <a:xfrm>
-            <a:off x="6995160" y="1626962"/>
-            <a:ext cx="4617720" cy="3604074"/>
+            <a:off x="7040880" y="1746280"/>
+            <a:ext cx="4663440" cy="3639758"/>
           </a:xfrm>
           <a:prstGeom prst="rect">
             <a:avLst/>
@@ -5547,16 +5529,40 @@
         <p:nvPr/>
       </p:nvGrpSpPr>
       <p:grpSpPr/>
-      <p:sp>
-        <p:nvSpPr>
-          <p:cNvPr id="2" name="Rectangle 1"/>
+      <p:pic>
+        <p:nvPicPr>
+          <p:cNvPr id="2" name="Picture 1" descr="bg_motif.png"/>
+          <p:cNvPicPr>
+            <a:picLocks noChangeAspect="1"/>
+          </p:cNvPicPr>
+          <p:nvPr/>
+        </p:nvPicPr>
+        <p:blipFill>
+          <a:blip r:embed="rId2"/>
+          <a:stretch>
+            <a:fillRect/>
+          </a:stretch>
+        </p:blipFill>
+        <p:spPr>
+          <a:xfrm>
+            <a:off x="0" y="0"/>
+            <a:ext cx="12191695" cy="6858000"/>
+          </a:xfrm>
+          <a:prstGeom prst="rect">
+            <a:avLst/>
+          </a:prstGeom>
+        </p:spPr>
+      </p:pic>
+      <p:sp>
+        <p:nvSpPr>
+          <p:cNvPr id="3" name="Rectangle 2"/>
           <p:cNvSpPr/>
           <p:nvPr/>
         </p:nvSpPr>
         <p:spPr>
           <a:xfrm>
             <a:off x="0" y="0"/>
-            <a:ext cx="12191695" cy="38100"/>
+            <a:ext cx="5486400" cy="38100"/>
           </a:xfrm>
           <a:prstGeom prst="rect">
             <a:avLst/>
@@ -5593,14 +5599,14 @@
       </p:sp>
       <p:sp>
         <p:nvSpPr>
-          <p:cNvPr id="3" name="TextBox 2"/>
+          <p:cNvPr id="4" name="TextBox 3"/>
           <p:cNvSpPr txBox="1"/>
           <p:nvPr/>
         </p:nvSpPr>
         <p:spPr>
           <a:xfrm>
-            <a:off x="777240" y="411480"/>
-            <a:ext cx="8686800" cy="365760"/>
+            <a:off x="777240" y="502920"/>
+            <a:ext cx="8229600" cy="320040"/>
           </a:xfrm>
           <a:prstGeom prst="rect">
             <a:avLst/>
@@ -5608,21 +5614,18 @@
           <a:noFill/>
         </p:spPr>
         <p:txBody>
-          <a:bodyPr wrap="square" lIns="25400" rIns="25400" tIns="12700" bIns="12700">
-            <a:noAutofit/>
+          <a:bodyPr wrap="square" anchor="t" lIns="0" rIns="0" tIns="0" bIns="0">
+            <a:spAutoFit/>
           </a:bodyPr>
           <a:lstStyle/>
           <a:p>
             <a:pPr algn="l">
               <a:lnSpc>
-                <a:spcPct val="128000"/>
+                <a:spcPct val="100000"/>
               </a:lnSpc>
-              <a:spcAft>
-                <a:spcPts val="400"/>
-              </a:spcAft>
             </a:pPr>
             <a:r>
-              <a:rPr sz="1100" b="1">
+              <a:rPr sz="1100" b="1" i="0">
                 <a:solidFill>
                   <a:srgbClr val="E7AC51"/>
                 </a:solidFill>
@@ -5635,14 +5638,14 @@
       </p:sp>
       <p:sp>
         <p:nvSpPr>
-          <p:cNvPr id="4" name="TextBox 3"/>
+          <p:cNvPr id="5" name="TextBox 4"/>
           <p:cNvSpPr txBox="1"/>
           <p:nvPr/>
         </p:nvSpPr>
         <p:spPr>
           <a:xfrm>
-            <a:off x="777240" y="2042414"/>
-            <a:ext cx="5989320" cy="904240"/>
+            <a:off x="777240" y="960120"/>
+            <a:ext cx="5943600" cy="1371600"/>
           </a:xfrm>
           <a:prstGeom prst="rect">
             <a:avLst/>
@@ -5650,21 +5653,18 @@
           <a:noFill/>
         </p:spPr>
         <p:txBody>
-          <a:bodyPr wrap="square" lIns="25400" rIns="25400" tIns="12700" bIns="12700">
-            <a:noAutofit/>
+          <a:bodyPr wrap="square" anchor="t" lIns="0" rIns="0" tIns="0" bIns="0">
+            <a:spAutoFit/>
           </a:bodyPr>
           <a:lstStyle/>
           <a:p>
             <a:pPr algn="l">
               <a:lnSpc>
-                <a:spcPct val="106000"/>
+                <a:spcPct val="112000"/>
               </a:lnSpc>
-              <a:spcAft>
-                <a:spcPts val="400"/>
-              </a:spcAft>
             </a:pPr>
             <a:r>
-              <a:rPr sz="2600" b="0">
+              <a:rPr sz="2500" b="1" i="0">
                 <a:solidFill>
                   <a:srgbClr val="ECEFF3"/>
                 </a:solidFill>
@@ -5673,7 +5673,7 @@
               <a:t>The frontier plateaued. </a:t>
             </a:r>
             <a:r>
-              <a:rPr sz="2600" b="0">
+              <a:rPr sz="2500" b="1" i="0">
                 <a:solidFill>
                   <a:srgbClr val="E7AC51"/>
                 </a:solidFill>
@@ -5686,14 +5686,14 @@
       </p:sp>
       <p:sp>
         <p:nvSpPr>
-          <p:cNvPr id="5" name="TextBox 4"/>
+          <p:cNvPr id="6" name="TextBox 5"/>
           <p:cNvSpPr txBox="1"/>
           <p:nvPr/>
         </p:nvSpPr>
         <p:spPr>
           <a:xfrm>
-            <a:off x="777240" y="2946654"/>
-            <a:ext cx="5989320" cy="346456"/>
+            <a:off x="777240" y="2240280"/>
+            <a:ext cx="5943600" cy="731520"/>
           </a:xfrm>
           <a:prstGeom prst="rect">
             <a:avLst/>
@@ -5701,30 +5701,27 @@
           <a:noFill/>
         </p:spPr>
         <p:txBody>
-          <a:bodyPr wrap="square" lIns="25400" rIns="25400" tIns="12700" bIns="12700">
-            <a:noAutofit/>
+          <a:bodyPr wrap="square" anchor="t" lIns="0" rIns="0" tIns="0" bIns="0">
+            <a:spAutoFit/>
           </a:bodyPr>
           <a:lstStyle/>
           <a:p>
             <a:pPr algn="l">
               <a:lnSpc>
-                <a:spcPct val="128000"/>
+                <a:spcPct val="125000"/>
               </a:lnSpc>
-              <a:spcAft>
-                <a:spcPts val="400"/>
-              </a:spcAft>
             </a:pPr>
             <a:r>
-              <a:rPr sz="1400" b="0">
-                <a:solidFill>
-                  <a:srgbClr val="E7AC51"/>
+              <a:rPr sz="1600" b="1" i="0">
+                <a:solidFill>
+                  <a:srgbClr val="ECEFF3"/>
                 </a:solidFill>
                 <a:latin typeface="Arial"/>
               </a:rPr>
               <a:t>Scale was no silver bullet — the failure was </a:t>
             </a:r>
             <a:r>
-              <a:rPr sz="1400" b="1">
+              <a:rPr sz="1600" b="1" i="0">
                 <a:solidFill>
                   <a:srgbClr val="E7AC51"/>
                 </a:solidFill>
@@ -5737,14 +5734,14 @@
       </p:sp>
       <p:sp>
         <p:nvSpPr>
-          <p:cNvPr id="6" name="TextBox 5"/>
+          <p:cNvPr id="7" name="TextBox 6"/>
           <p:cNvSpPr txBox="1"/>
           <p:nvPr/>
         </p:nvSpPr>
         <p:spPr>
           <a:xfrm>
-            <a:off x="777240" y="3293110"/>
-            <a:ext cx="5989320" cy="1484375"/>
+            <a:off x="777240" y="3200400"/>
+            <a:ext cx="5943600" cy="2377440"/>
           </a:xfrm>
           <a:prstGeom prst="rect">
             <a:avLst/>
@@ -5752,21 +5749,18 @@
           <a:noFill/>
         </p:spPr>
         <p:txBody>
-          <a:bodyPr wrap="square" lIns="25400" rIns="25400" tIns="12700" bIns="12700">
-            <a:noAutofit/>
+          <a:bodyPr wrap="square" anchor="t" lIns="0" rIns="0" tIns="0" bIns="0">
+            <a:spAutoFit/>
           </a:bodyPr>
           <a:lstStyle/>
           <a:p>
             <a:pPr algn="l">
               <a:lnSpc>
-                <a:spcPct val="128000"/>
+                <a:spcPct val="140000"/>
               </a:lnSpc>
-              <a:spcAft>
-                <a:spcPts val="400"/>
-              </a:spcAft>
             </a:pPr>
             <a:r>
-              <a:rPr sz="1400" b="0">
+              <a:rPr sz="1350" b="0" i="0">
                 <a:solidFill>
                   <a:srgbClr val="9DA9B5"/>
                 </a:solidFill>
@@ -5775,7 +5769,7 @@
               <a:t>Frontier models aced the exam, then degraded on real clinical data — a model trained on the whole internet </a:t>
             </a:r>
             <a:r>
-              <a:rPr sz="1400" b="1">
+              <a:rPr sz="1350" b="1" i="0">
                 <a:solidFill>
                   <a:srgbClr val="ECEFF3"/>
                 </a:solidFill>
@@ -5784,25 +5778,25 @@
               <a:t>reasons from text priors, not the pixels in front of it.</a:t>
             </a:r>
             <a:r>
-              <a:rPr sz="1400" b="0">
+              <a:rPr sz="1350" b="0" i="0">
                 <a:solidFill>
                   <a:srgbClr val="9DA9B5"/>
                 </a:solidFill>
                 <a:latin typeface="Arial"/>
               </a:rPr>
-              <a:t> By 2035 that stopped being a footnote and became the market structure: generalists won the </a:t>
-            </a:r>
-            <a:r>
-              <a:rPr sz="1400" b="1">
-                <a:solidFill>
-                  <a:srgbClr val="ECEFF3"/>
+              <a:t> By 2035 that hardened into market structure: generalists won the </a:t>
+            </a:r>
+            <a:r>
+              <a:rPr sz="1350" b="1" i="0">
+                <a:solidFill>
+                  <a:srgbClr val="E7AC51"/>
                 </a:solidFill>
                 <a:latin typeface="Arial"/>
               </a:rPr>
               <a:t>data tier</a:t>
             </a:r>
             <a:r>
-              <a:rPr sz="1400" b="0">
+              <a:rPr sz="1350" b="0" i="0">
                 <a:solidFill>
                   <a:srgbClr val="9DA9B5"/>
                 </a:solidFill>
@@ -5811,9 +5805,9 @@
               <a:t> (extract, harmonize, label — human signs off); domain models own the </a:t>
             </a:r>
             <a:r>
-              <a:rPr sz="1400" b="1">
-                <a:solidFill>
-                  <a:srgbClr val="ECEFF3"/>
+              <a:rPr sz="1350" b="1" i="0">
+                <a:solidFill>
+                  <a:srgbClr val="E7AC51"/>
                 </a:solidFill>
                 <a:latin typeface="Arial"/>
               </a:rPr>
@@ -5824,14 +5818,14 @@
       </p:sp>
       <p:sp>
         <p:nvSpPr>
-          <p:cNvPr id="7" name="TextBox 6"/>
+          <p:cNvPr id="8" name="TextBox 7"/>
           <p:cNvSpPr txBox="1"/>
           <p:nvPr/>
         </p:nvSpPr>
         <p:spPr>
           <a:xfrm>
-            <a:off x="777240" y="4777486"/>
-            <a:ext cx="5989320" cy="586740"/>
+            <a:off x="777240" y="5852160"/>
+            <a:ext cx="5943600" cy="548640"/>
           </a:xfrm>
           <a:prstGeom prst="rect">
             <a:avLst/>
@@ -5839,8 +5833,8 @@
           <a:noFill/>
         </p:spPr>
         <p:txBody>
-          <a:bodyPr wrap="square" lIns="25400" rIns="25400" tIns="12700" bIns="12700">
-            <a:noAutofit/>
+          <a:bodyPr wrap="square" anchor="t" lIns="0" rIns="0" tIns="0" bIns="0">
+            <a:spAutoFit/>
           </a:bodyPr>
           <a:lstStyle/>
           <a:p>
@@ -5848,40 +5842,37 @@
               <a:lnSpc>
                 <a:spcPct val="130000"/>
               </a:lnSpc>
-              <a:spcAft>
-                <a:spcPts val="400"/>
-              </a:spcAft>
             </a:pPr>
             <a:r>
-              <a:rPr sz="1000" b="0">
+              <a:rPr sz="950" b="0" i="0">
                 <a:solidFill>
                   <a:srgbClr val="5C6975"/>
                 </a:solidFill>
                 <a:latin typeface="Consolas"/>
               </a:rPr>
-              <a:t>Wu, JMIR 2025 (e84120) · Raji/Daneshjou/Alsentzer, NEJM AI 2025 · RadFlag, arXiv:2411.00299 · Abdullah &amp; Kim, JMIR Med Inform 2025 · ScaleMAI, arXiv:2501.03410 · Mammo-CLIP, ECCV 2024</a:t>
+              <a:t>Wu, JMIR 2025 (e84120) · Raji/Daneshjou/Alsentzer, NEJM AI 2025 · RadFlag · Abdullah &amp; Kim, JMIR 2025 · ScaleMAI · Mammo-CLIP.</a:t>
             </a:r>
           </a:p>
         </p:txBody>
       </p:sp>
       <p:pic>
         <p:nvPicPr>
-          <p:cNvPr id="8" name="Picture 7" descr="s_2f6bf6fcb8.png"/>
+          <p:cNvPr id="9" name="Picture 8" descr="svg_e3ce8206fb.png"/>
           <p:cNvPicPr>
             <a:picLocks noChangeAspect="1"/>
           </p:cNvPicPr>
           <p:nvPr/>
         </p:nvPicPr>
         <p:blipFill>
-          <a:blip r:embed="rId3"/>
+          <a:blip r:embed="rId4"/>
           <a:stretch>
             <a:fillRect/>
           </a:stretch>
         </p:blipFill>
         <p:spPr>
           <a:xfrm>
-            <a:off x="6995160" y="1314570"/>
-            <a:ext cx="4617720" cy="4228859"/>
+            <a:off x="7040880" y="1430795"/>
+            <a:ext cx="4663440" cy="4270729"/>
           </a:xfrm>
           <a:prstGeom prst="rect">
             <a:avLst/>

</xml_diff>